<commit_message>
style: adjust layout spacing and text typography in presentation slides and remove count pill from literature scope
</commit_message>
<xml_diff>
--- a/docs/presentation/file-3/slide-09-research-gap.pptx
+++ b/docs/presentation/file-3/slide-09-research-gap.pptx
@@ -1236,11 +1236,11 @@
         <p:spPr>
           <a:xfrm>
             <a:off x="1047750" y="4381500"/>
-            <a:ext cx="2984500" cy="1238250"/>
+            <a:ext cx="2984500" cy="904875"/>
           </a:xfrm>
           <a:prstGeom prst="rect">
             <a:avLst>
-              <a:gd name="adj" fmla="val 1477"/>
+              <a:gd name="adj" fmla="val 2021"/>
             </a:avLst>
           </a:prstGeom>
           <a:solidFill>
@@ -1265,7 +1265,7 @@
         <p:spPr>
           <a:xfrm>
             <a:off x="1047750" y="4381500"/>
-            <a:ext cx="28575" cy="1238250"/>
+            <a:ext cx="28575" cy="904875"/>
           </a:xfrm>
           <a:prstGeom prst="rect">
             <a:avLst/>
@@ -1285,7 +1285,7 @@
         <p:spPr>
           <a:xfrm>
             <a:off x="1200150" y="4381500"/>
-            <a:ext cx="2717800" cy="1238250"/>
+            <a:ext cx="2717800" cy="904875"/>
           </a:xfrm>
           <a:prstGeom prst="rect">
             <a:avLst/>
@@ -1326,8 +1326,8 @@
         </p:nvSpPr>
         <p:spPr>
           <a:xfrm>
-            <a:off x="4318000" y="3682365"/>
-            <a:ext cx="0" cy="1722120"/>
+            <a:off x="4318000" y="3649027"/>
+            <a:ext cx="0" cy="1455420"/>
           </a:xfrm>
           <a:prstGeom prst="line">
             <a:avLst/>
@@ -1467,11 +1467,11 @@
         <p:spPr>
           <a:xfrm>
             <a:off x="4603750" y="4381500"/>
-            <a:ext cx="2984500" cy="1238250"/>
+            <a:ext cx="2984500" cy="904875"/>
           </a:xfrm>
           <a:prstGeom prst="rect">
             <a:avLst>
-              <a:gd name="adj" fmla="val 1477"/>
+              <a:gd name="adj" fmla="val 2021"/>
             </a:avLst>
           </a:prstGeom>
           <a:solidFill>
@@ -1496,7 +1496,7 @@
         <p:spPr>
           <a:xfrm>
             <a:off x="4603750" y="4381500"/>
-            <a:ext cx="28575" cy="1238250"/>
+            <a:ext cx="28575" cy="904875"/>
           </a:xfrm>
           <a:prstGeom prst="rect">
             <a:avLst/>
@@ -1516,7 +1516,7 @@
         <p:spPr>
           <a:xfrm>
             <a:off x="4756150" y="4381500"/>
-            <a:ext cx="2717800" cy="1238250"/>
+            <a:ext cx="2717800" cy="904875"/>
           </a:xfrm>
           <a:prstGeom prst="rect">
             <a:avLst/>
@@ -1557,8 +1557,8 @@
         </p:nvSpPr>
         <p:spPr>
           <a:xfrm>
-            <a:off x="7874000" y="3682365"/>
-            <a:ext cx="0" cy="1722120"/>
+            <a:off x="7874000" y="3649027"/>
+            <a:ext cx="0" cy="1455420"/>
           </a:xfrm>
           <a:prstGeom prst="line">
             <a:avLst/>
@@ -1698,11 +1698,11 @@
         <p:spPr>
           <a:xfrm>
             <a:off x="8159750" y="4381500"/>
-            <a:ext cx="2984500" cy="1238250"/>
+            <a:ext cx="2984500" cy="904875"/>
           </a:xfrm>
           <a:prstGeom prst="rect">
             <a:avLst>
-              <a:gd name="adj" fmla="val 1477"/>
+              <a:gd name="adj" fmla="val 2021"/>
             </a:avLst>
           </a:prstGeom>
           <a:solidFill>
@@ -1727,7 +1727,7 @@
         <p:spPr>
           <a:xfrm>
             <a:off x="8159750" y="4381500"/>
-            <a:ext cx="28575" cy="1238250"/>
+            <a:ext cx="28575" cy="904875"/>
           </a:xfrm>
           <a:prstGeom prst="rect">
             <a:avLst/>
@@ -1747,7 +1747,7 @@
         <p:spPr>
           <a:xfrm>
             <a:off x="8312150" y="4381500"/>
-            <a:ext cx="2717800" cy="1238250"/>
+            <a:ext cx="2717800" cy="904875"/>
           </a:xfrm>
           <a:prstGeom prst="rect">
             <a:avLst/>
@@ -1782,14 +1782,63 @@
       </p:sp>
       <p:sp>
         <p:nvSpPr>
-          <p:cNvPr id="27" name="Text 25"/>
+          <p:cNvPr id="27" name="Shape 25"/>
+          <p:cNvSpPr/>
+          <p:nvPr/>
+        </p:nvSpPr>
+        <p:spPr>
+          <a:xfrm>
+            <a:off x="2788920" y="5534025"/>
+            <a:ext cx="6614160" cy="590550"/>
+          </a:xfrm>
+          <a:prstGeom prst="rect">
+            <a:avLst>
+              <a:gd name="adj" fmla="val 6968"/>
+            </a:avLst>
+          </a:prstGeom>
+          <a:solidFill>
+            <a:srgbClr val="FDFDFD"/>
+          </a:solidFill>
+          <a:ln/>
+          <a:effectLst>
+            <a:outerShdw sx="100000" sy="100000" kx="0" ky="0" algn="bl" rotWithShape="0" blurRad="127000" dist="38100" dir="5400000">
+              <a:srgbClr val="000000">
+                <a:alpha val="10000"/>
+              </a:srgbClr>
+            </a:outerShdw>
+          </a:effectLst>
+        </p:spPr>
+      </p:sp>
+      <p:sp>
+        <p:nvSpPr>
+          <p:cNvPr id="28" name="Shape 26"/>
+          <p:cNvSpPr/>
+          <p:nvPr/>
+        </p:nvSpPr>
+        <p:spPr>
+          <a:xfrm>
+            <a:off x="2788920" y="5534025"/>
+            <a:ext cx="38100" cy="590550"/>
+          </a:xfrm>
+          <a:prstGeom prst="rect">
+            <a:avLst/>
+          </a:prstGeom>
+          <a:solidFill>
+            <a:srgbClr val="8B1A1A"/>
+          </a:solidFill>
+          <a:ln/>
+        </p:spPr>
+      </p:sp>
+      <p:sp>
+        <p:nvSpPr>
+          <p:cNvPr id="29" name="Text 27"/>
           <p:cNvSpPr txBox="1"/>
           <p:nvPr/>
         </p:nvSpPr>
         <p:spPr>
           <a:xfrm>
-            <a:off x="1295400" y="5905500"/>
-            <a:ext cx="9601200" cy="247650"/>
+            <a:off x="2979420" y="5534025"/>
+            <a:ext cx="6309360" cy="590550"/>
           </a:xfrm>
           <a:prstGeom prst="rect">
             <a:avLst/>
@@ -1805,7 +1854,7 @@
               <a:buNone/>
             </a:pPr>
             <a:r>
-              <a:rPr lang="en-US" sz="1600" b="1" spc="40" kern="0" dirty="0">
+              <a:rPr lang="en-US" sz="1550" b="1" spc="30" kern="0" dirty="0">
                 <a:solidFill>
                   <a:srgbClr val="1A1A2E"/>
                 </a:solidFill>
@@ -1819,7 +1868,7 @@
               <a:buNone/>
             </a:pPr>
             <a:r>
-              <a:rPr lang="en-US" sz="1600" b="1" spc="40" kern="0" dirty="0">
+              <a:rPr lang="en-US" sz="1550" b="1" spc="30" kern="0" dirty="0">
                 <a:solidFill>
                   <a:srgbClr val="8B1A1A"/>
                 </a:solidFill>
@@ -1833,7 +1882,7 @@
               <a:buNone/>
             </a:pPr>
             <a:r>
-              <a:rPr lang="en-US" sz="1600" b="1" spc="40" kern="0" dirty="0">
+              <a:rPr lang="en-US" sz="1550" b="1" spc="30" kern="0" dirty="0">
                 <a:solidFill>
                   <a:srgbClr val="1A1A2E"/>
                 </a:solidFill>
@@ -1843,13 +1892,13 @@
               </a:rPr>
               <a:t> is designed to investigate.</a:t>
             </a:r>
-            <a:endParaRPr lang="en-US" sz="1600" dirty="0"/>
-          </a:p>
-        </p:txBody>
-      </p:sp>
-      <p:sp>
-        <p:nvSpPr>
-          <p:cNvPr id="28" name="Shape 26"/>
+            <a:endParaRPr lang="en-US" sz="1550" dirty="0"/>
+          </a:p>
+        </p:txBody>
+      </p:sp>
+      <p:sp>
+        <p:nvSpPr>
+          <p:cNvPr id="30" name="Shape 28"/>
           <p:cNvSpPr/>
           <p:nvPr/>
         </p:nvSpPr>
@@ -1872,7 +1921,7 @@
       </p:sp>
       <p:sp>
         <p:nvSpPr>
-          <p:cNvPr id="29" name="Text 27"/>
+          <p:cNvPr id="31" name="Text 29"/>
           <p:cNvSpPr txBox="1"/>
           <p:nvPr/>
         </p:nvSpPr>
@@ -1911,7 +1960,7 @@
       </p:sp>
       <p:sp>
         <p:nvSpPr>
-          <p:cNvPr id="30" name="Shape 28"/>
+          <p:cNvPr id="32" name="Shape 30"/>
           <p:cNvSpPr/>
           <p:nvPr/>
         </p:nvSpPr>

</xml_diff>